<commit_message>
Four Connects diagram rebuilt: box text properly centered
The source PNG had drifting box captions (box 4's text ran to its
border). Rebuilt at the same size and palette with centered text
throughout (PIL, Cambria), replacing the image on all 22 grounding
slides and the covering-briefing source image. Decks re-synced.

Co-Authored-By: Claude Fable 5 <noreply@anthropic.com>
</commit_message>
<xml_diff>
--- a/_implementation-notes/evening-series/FotH Evening Session 10 Slides DRAFT v1.pptx
+++ b/_implementation-notes/evening-series/FotH Evening Session 10 Slides DRAFT v1.pptx
@@ -4855,6 +4855,278 @@
                 </a:solidFill>
                 <a:latin typeface="Cambria"/>
               </a:rPr>
+              <a:t>Merge and One-Word Landing</a:t>
+            </a:r>
+          </a:p>
+        </p:txBody>
+      </p:sp>
+      <p:sp>
+        <p:nvSpPr>
+          <p:cNvPr id="4" name="TextBox 4"/>
+          <p:cNvSpPr txBox="1"/>
+          <p:nvPr/>
+        </p:nvSpPr>
+        <p:spPr>
+          <a:xfrm>
+            <a:off x="822960" y="1554480"/>
+            <a:ext cx="10515600" cy="4892040"/>
+          </a:xfrm>
+          <a:prstGeom prst="rect">
+            <a:avLst/>
+          </a:prstGeom>
+          <a:noFill/>
+        </p:spPr>
+        <p:txBody>
+          <a:bodyPr wrap="square" lIns="91440" tIns="91440" rIns="91440" bIns="91440"/>
+          <a:lstStyle/>
+          <a:p>
+            <a:pPr marL="274320" indent="-274320">
+              <a:spcAft>
+                <a:spcPts val="900"/>
+              </a:spcAft>
+            </a:pPr>
+            <a:r>
+              <a:rPr sz="2800" b="1" i="0">
+                <a:solidFill>
+                  <a:srgbClr val="97BC62"/>
+                </a:solidFill>
+                <a:latin typeface="Calibri"/>
+              </a:rPr>
+              <a:t>•  </a:t>
+            </a:r>
+            <a:r>
+              <a:rPr sz="2800" b="0" i="0">
+                <a:solidFill>
+                  <a:srgbClr val="222B22"/>
+                </a:solidFill>
+                <a:latin typeface="Calibri"/>
+              </a:rPr>
+              <a:t>“What happened in your pair stays in your pair.”</a:t>
+            </a:r>
+          </a:p>
+          <a:p>
+            <a:pPr marL="274320" indent="-274320">
+              <a:spcAft>
+                <a:spcPts val="900"/>
+              </a:spcAft>
+            </a:pPr>
+            <a:r>
+              <a:rPr sz="2800" b="1" i="0">
+                <a:solidFill>
+                  <a:srgbClr val="97BC62"/>
+                </a:solidFill>
+                <a:latin typeface="Calibri"/>
+              </a:rPr>
+              <a:t>•  </a:t>
+            </a:r>
+            <a:r>
+              <a:rPr sz="2800" b="0" i="0">
+                <a:solidFill>
+                  <a:srgbClr val="222B22"/>
+                </a:solidFill>
+                <a:latin typeface="Calibri"/>
+              </a:rPr>
+              <a:t>One word each, when you’re ready — not what was said, but what you noticed; you can pass</a:t>
+            </a:r>
+          </a:p>
+          <a:p>
+            <a:pPr marL="685800" indent="-274320">
+              <a:spcAft>
+                <a:spcPts val="700"/>
+              </a:spcAft>
+            </a:pPr>
+            <a:r>
+              <a:rPr sz="2000" b="1" i="0">
+                <a:solidFill>
+                  <a:srgbClr val="97BC62"/>
+                </a:solidFill>
+                <a:latin typeface="Calibri"/>
+              </a:rPr>
+              <a:t>–  </a:t>
+            </a:r>
+            <a:r>
+              <a:rPr sz="2000" b="0" i="1">
+                <a:solidFill>
+                  <a:srgbClr val="222B22"/>
+                </a:solidFill>
+                <a:latin typeface="Calibri"/>
+              </a:rPr>
+              <a:t>“Deeper.” “Same.” “Tender.” “Quiet.” “Harder.” “Found.”</a:t>
+            </a:r>
+          </a:p>
+          <a:p>
+            <a:pPr marL="274320" indent="-274320">
+              <a:spcAft>
+                <a:spcPts val="900"/>
+              </a:spcAft>
+            </a:pPr>
+            <a:r>
+              <a:rPr sz="2800" b="1" i="0">
+                <a:solidFill>
+                  <a:srgbClr val="97BC62"/>
+                </a:solidFill>
+                <a:latin typeface="Calibri"/>
+              </a:rPr>
+              <a:t>•  </a:t>
+            </a:r>
+            <a:r>
+              <a:rPr sz="2800" b="0" i="0">
+                <a:solidFill>
+                  <a:srgbClr val="222B22"/>
+                </a:solidFill>
+                <a:latin typeface="Calibri"/>
+              </a:rPr>
+              <a:t>A parent offers the first word — each one received without commentary</a:t>
+            </a:r>
+          </a:p>
+          <a:p>
+            <a:pPr marL="274320" indent="-274320">
+              <a:spcAft>
+                <a:spcPts val="900"/>
+              </a:spcAft>
+            </a:pPr>
+            <a:r>
+              <a:rPr sz="2800" b="1" i="0">
+                <a:solidFill>
+                  <a:srgbClr val="97BC62"/>
+                </a:solidFill>
+                <a:latin typeface="Calibri"/>
+              </a:rPr>
+              <a:t>•  </a:t>
+            </a:r>
+            <a:r>
+              <a:rPr sz="2800" b="0" i="0">
+                <a:solidFill>
+                  <a:srgbClr val="222B22"/>
+                </a:solidFill>
+                <a:latin typeface="Calibri"/>
+              </a:rPr>
+              <a:t>“A garden visited twice is a garden being tended. Whatever He is doing in yours, He will keep doing it this week.”</a:t>
+            </a:r>
+          </a:p>
+        </p:txBody>
+      </p:sp>
+      <p:sp>
+        <p:nvSpPr>
+          <p:cNvPr id="90" name="SlideNum"/>
+          <p:cNvSpPr txBox="1"/>
+          <p:nvPr/>
+        </p:nvSpPr>
+        <p:spPr>
+          <a:xfrm>
+            <a:off x="11384280" y="6446520"/>
+            <a:ext cx="640080" cy="292608"/>
+          </a:xfrm>
+          <a:prstGeom prst="rect">
+            <a:avLst/>
+          </a:prstGeom>
+          <a:noFill/>
+        </p:spPr>
+        <p:txBody>
+          <a:bodyPr wrap="none" lIns="0" tIns="0" rIns="45720" bIns="0" anchor="ctr"/>
+          <a:lstStyle/>
+          <a:p>
+            <a:pPr algn="r"/>
+            <a:r>
+              <a:t>133</a:t>
+            </a:r>
+            <a:endParaRPr sz="1000" b="1">
+              <a:solidFill>
+                <a:srgbClr val="7A8A6E"/>
+              </a:solidFill>
+              <a:latin typeface="Calibri"/>
+            </a:endParaRPr>
+          </a:p>
+        </p:txBody>
+      </p:sp>
+    </p:spTree>
+  </p:cSld>
+  <p:clrMapOvr>
+    <a:masterClrMapping/>
+  </p:clrMapOvr>
+</p:sld>
+</file>
+
+<file path=ppt/slides/slide11.xml><?xml version="1.0" encoding="utf-8"?>
+<p:sld xmlns:a="http://schemas.openxmlformats.org/drawingml/2006/main" xmlns:r="http://schemas.openxmlformats.org/officeDocument/2006/relationships" xmlns:p="http://schemas.openxmlformats.org/presentationml/2006/main">
+  <p:cSld>
+    <p:spTree>
+      <p:nvGrpSpPr>
+        <p:cNvPr id="1" name=""/>
+        <p:cNvGrpSpPr/>
+        <p:nvPr/>
+      </p:nvGrpSpPr>
+      <p:grpSpPr>
+        <a:xfrm>
+          <a:off x="0" y="0"/>
+          <a:ext cx="0" cy="0"/>
+          <a:chOff x="0" y="0"/>
+          <a:chExt cx="0" cy="0"/>
+        </a:xfrm>
+      </p:grpSpPr>
+      <p:sp>
+        <p:nvSpPr>
+          <p:cNvPr id="2" name="Rectangle 1"/>
+          <p:cNvSpPr/>
+          <p:nvPr/>
+        </p:nvSpPr>
+        <p:spPr>
+          <a:xfrm>
+            <a:off x="0" y="0"/>
+            <a:ext cx="12191695" cy="6858000"/>
+          </a:xfrm>
+          <a:prstGeom prst="rect">
+            <a:avLst/>
+          </a:prstGeom>
+          <a:solidFill>
+            <a:srgbClr val="FFFFFF"/>
+          </a:solidFill>
+          <a:ln>
+            <a:noFill/>
+          </a:ln>
+        </p:spPr>
+        <p:txBody>
+          <a:bodyPr/>
+          <a:lstStyle/>
+          <a:p>
+            <a:endParaRPr/>
+          </a:p>
+        </p:txBody>
+      </p:sp>
+      <p:sp>
+        <p:nvSpPr>
+          <p:cNvPr id="3" name="TextBox 2"/>
+          <p:cNvSpPr txBox="1"/>
+          <p:nvPr/>
+        </p:nvSpPr>
+        <p:spPr>
+          <a:xfrm>
+            <a:off x="822960" y="502920"/>
+            <a:ext cx="10515600" cy="822960"/>
+          </a:xfrm>
+          <a:prstGeom prst="rect">
+            <a:avLst/>
+          </a:prstGeom>
+          <a:noFill/>
+        </p:spPr>
+        <p:txBody>
+          <a:bodyPr wrap="square">
+            <a:spAutoFit/>
+          </a:bodyPr>
+          <a:lstStyle/>
+          <a:p>
+            <a:pPr algn="l">
+              <a:spcAft>
+                <a:spcPts val="600"/>
+              </a:spcAft>
+            </a:pPr>
+            <a:r>
+              <a:rPr sz="2800" b="1" i="0">
+                <a:solidFill>
+                  <a:srgbClr val="2C5F2D"/>
+                </a:solidFill>
+                <a:latin typeface="Cambria"/>
+              </a:rPr>
               <a:t>Homework — Two Weeks, Four Parts</a:t>
             </a:r>
           </a:p>
@@ -5084,6 +5356,390 @@
 </file>
 
 <file path=ppt/slides/slide12.xml><?xml version="1.0" encoding="utf-8"?>
+<p:sld xmlns:a="http://schemas.openxmlformats.org/drawingml/2006/main" xmlns:p="http://schemas.openxmlformats.org/presentationml/2006/main" xmlns:r="http://schemas.openxmlformats.org/officeDocument/2006/relationships">
+  <p:cSld>
+    <p:spTree>
+      <p:nvGrpSpPr>
+        <p:cNvPr id="1" name=""/>
+        <p:cNvGrpSpPr/>
+        <p:nvPr/>
+      </p:nvGrpSpPr>
+      <p:grpSpPr/>
+      <p:sp>
+        <p:nvSpPr>
+          <p:cNvPr id="2" name="Rectangle 1"/>
+          <p:cNvSpPr/>
+          <p:nvPr/>
+        </p:nvSpPr>
+        <p:spPr>
+          <a:xfrm>
+            <a:off x="0" y="0"/>
+            <a:ext cx="12192000" cy="6858000"/>
+          </a:xfrm>
+          <a:prstGeom prst="rect">
+            <a:avLst/>
+          </a:prstGeom>
+          <a:solidFill>
+            <a:srgbClr val="FFFFFF"/>
+          </a:solidFill>
+          <a:ln>
+            <a:noFill/>
+          </a:ln>
+          <a:effectLst/>
+        </p:spPr>
+        <p:style>
+          <a:lnRef idx="1">
+            <a:schemeClr val="accent1"/>
+          </a:lnRef>
+          <a:fillRef idx="3">
+            <a:schemeClr val="accent1"/>
+          </a:fillRef>
+          <a:effectRef idx="2">
+            <a:schemeClr val="accent1"/>
+          </a:effectRef>
+          <a:fontRef idx="minor">
+            <a:schemeClr val="lt1"/>
+          </a:fontRef>
+        </p:style>
+        <p:txBody>
+          <a:bodyPr rtlCol="0" anchor="ctr"/>
+          <a:lstStyle/>
+          <a:p>
+            <a:pPr algn="ctr"/>
+          </a:p>
+        </p:txBody>
+      </p:sp>
+      <p:sp>
+        <p:nvSpPr>
+          <p:cNvPr id="3" name="TextBox 2"/>
+          <p:cNvSpPr txBox="1"/>
+          <p:nvPr/>
+        </p:nvSpPr>
+        <p:spPr>
+          <a:xfrm>
+            <a:off x="822960" y="502920"/>
+            <a:ext cx="10515600" cy="822960"/>
+          </a:xfrm>
+          <a:prstGeom prst="rect">
+            <a:avLst/>
+          </a:prstGeom>
+          <a:noFill/>
+        </p:spPr>
+        <p:txBody>
+          <a:bodyPr wrap="square">
+            <a:spAutoFit/>
+          </a:bodyPr>
+          <a:lstStyle/>
+          <a:p>
+            <a:r>
+              <a:rPr sz="2800" b="1">
+                <a:solidFill>
+                  <a:srgbClr val="2C5F2D"/>
+                </a:solidFill>
+                <a:latin typeface="Cambria"/>
+              </a:rPr>
+              <a:t>The Take-Home Sheet — the Daily Rhythm</a:t>
+            </a:r>
+          </a:p>
+        </p:txBody>
+      </p:sp>
+      <p:pic>
+        <p:nvPicPr>
+          <p:cNvPr id="4" name="Picture 3" descr="s10_part1.png"/>
+          <p:cNvPicPr>
+            <a:picLocks noChangeAspect="1"/>
+          </p:cNvPicPr>
+          <p:nvPr/>
+        </p:nvPicPr>
+        <p:blipFill>
+          <a:blip r:embed="rId2"/>
+          <a:stretch>
+            <a:fillRect/>
+          </a:stretch>
+        </p:blipFill>
+        <p:spPr>
+          <a:xfrm>
+            <a:off x="1798167" y="1463040"/>
+            <a:ext cx="8595360" cy="4457308"/>
+          </a:xfrm>
+          <a:prstGeom prst="rect">
+            <a:avLst/>
+          </a:prstGeom>
+          <a:ln w="12700">
+            <a:solidFill>
+              <a:srgbClr val="C8C8C8"/>
+            </a:solidFill>
+          </a:ln>
+        </p:spPr>
+      </p:pic>
+      <p:sp>
+        <p:nvSpPr>
+          <p:cNvPr id="5" name="TextBox 4"/>
+          <p:cNvSpPr txBox="1"/>
+          <p:nvPr/>
+        </p:nvSpPr>
+        <p:spPr>
+          <a:xfrm>
+            <a:off x="822960" y="6355080"/>
+            <a:ext cx="10515600" cy="411480"/>
+          </a:xfrm>
+          <a:prstGeom prst="rect">
+            <a:avLst/>
+          </a:prstGeom>
+          <a:noFill/>
+        </p:spPr>
+        <p:txBody>
+          <a:bodyPr wrap="square">
+            <a:spAutoFit/>
+          </a:bodyPr>
+          <a:lstStyle/>
+          <a:p>
+            <a:r>
+              <a:rPr sz="1400" i="1">
+                <a:solidFill>
+                  <a:srgbClr val="595959"/>
+                </a:solidFill>
+                <a:latin typeface="Calibri"/>
+              </a:rPr>
+              <a:t>Handed out now — this is the sheet in your hands.</a:t>
+            </a:r>
+          </a:p>
+        </p:txBody>
+      </p:sp>
+      <p:sp>
+        <p:nvSpPr>
+          <p:cNvPr id="90" name="SlideNum"/>
+          <p:cNvSpPr txBox="1"/>
+          <p:nvPr/>
+        </p:nvSpPr>
+        <p:spPr>
+          <a:xfrm>
+            <a:off x="11384280" y="6446520"/>
+            <a:ext cx="640080" cy="292608"/>
+          </a:xfrm>
+          <a:prstGeom prst="rect">
+            <a:avLst/>
+          </a:prstGeom>
+          <a:noFill/>
+        </p:spPr>
+        <p:txBody>
+          <a:bodyPr wrap="none" lIns="0" tIns="0" rIns="45720" bIns="0" anchor="ctr"/>
+          <a:lstStyle/>
+          <a:p>
+            <a:pPr algn="r"/>
+            <a:r>
+              <a:t>135</a:t>
+            </a:r>
+            <a:endParaRPr sz="1000" b="1">
+              <a:solidFill>
+                <a:srgbClr val="7A8A6E"/>
+              </a:solidFill>
+              <a:latin typeface="Calibri"/>
+            </a:endParaRPr>
+          </a:p>
+        </p:txBody>
+      </p:sp>
+    </p:spTree>
+  </p:cSld>
+  <p:clrMapOvr>
+    <a:masterClrMapping/>
+  </p:clrMapOvr>
+</p:sld>
+</file>
+
+<file path=ppt/slides/slide13.xml><?xml version="1.0" encoding="utf-8"?>
+<p:sld xmlns:a="http://schemas.openxmlformats.org/drawingml/2006/main" xmlns:p="http://schemas.openxmlformats.org/presentationml/2006/main" xmlns:r="http://schemas.openxmlformats.org/officeDocument/2006/relationships">
+  <p:cSld>
+    <p:spTree>
+      <p:nvGrpSpPr>
+        <p:cNvPr id="1" name=""/>
+        <p:cNvGrpSpPr/>
+        <p:nvPr/>
+      </p:nvGrpSpPr>
+      <p:grpSpPr/>
+      <p:sp>
+        <p:nvSpPr>
+          <p:cNvPr id="2" name="Rectangle 1"/>
+          <p:cNvSpPr/>
+          <p:nvPr/>
+        </p:nvSpPr>
+        <p:spPr>
+          <a:xfrm>
+            <a:off x="0" y="0"/>
+            <a:ext cx="12192000" cy="6858000"/>
+          </a:xfrm>
+          <a:prstGeom prst="rect">
+            <a:avLst/>
+          </a:prstGeom>
+          <a:solidFill>
+            <a:srgbClr val="FFFFFF"/>
+          </a:solidFill>
+          <a:ln>
+            <a:noFill/>
+          </a:ln>
+          <a:effectLst/>
+        </p:spPr>
+        <p:style>
+          <a:lnRef idx="1">
+            <a:schemeClr val="accent1"/>
+          </a:lnRef>
+          <a:fillRef idx="3">
+            <a:schemeClr val="accent1"/>
+          </a:fillRef>
+          <a:effectRef idx="2">
+            <a:schemeClr val="accent1"/>
+          </a:effectRef>
+          <a:fontRef idx="minor">
+            <a:schemeClr val="lt1"/>
+          </a:fontRef>
+        </p:style>
+        <p:txBody>
+          <a:bodyPr rtlCol="0" anchor="ctr"/>
+          <a:lstStyle/>
+          <a:p>
+            <a:pPr algn="ctr"/>
+          </a:p>
+        </p:txBody>
+      </p:sp>
+      <p:sp>
+        <p:nvSpPr>
+          <p:cNvPr id="3" name="TextBox 2"/>
+          <p:cNvSpPr txBox="1"/>
+          <p:nvPr/>
+        </p:nvSpPr>
+        <p:spPr>
+          <a:xfrm>
+            <a:off x="822960" y="502920"/>
+            <a:ext cx="10515600" cy="822960"/>
+          </a:xfrm>
+          <a:prstGeom prst="rect">
+            <a:avLst/>
+          </a:prstGeom>
+          <a:noFill/>
+        </p:spPr>
+        <p:txBody>
+          <a:bodyPr wrap="square">
+            <a:spAutoFit/>
+          </a:bodyPr>
+          <a:lstStyle/>
+          <a:p>
+            <a:r>
+              <a:rPr sz="2800" b="1">
+                <a:solidFill>
+                  <a:srgbClr val="2C5F2D"/>
+                </a:solidFill>
+                <a:latin typeface="Cambria"/>
+              </a:rPr>
+              <a:t>The Take-Home Sheet — the Four Parts</a:t>
+            </a:r>
+          </a:p>
+        </p:txBody>
+      </p:sp>
+      <p:pic>
+        <p:nvPicPr>
+          <p:cNvPr id="4" name="Picture 3" descr="s10_part2.png"/>
+          <p:cNvPicPr>
+            <a:picLocks noChangeAspect="1"/>
+          </p:cNvPicPr>
+          <p:nvPr/>
+        </p:nvPicPr>
+        <p:blipFill>
+          <a:blip r:embed="rId2"/>
+          <a:stretch>
+            <a:fillRect/>
+          </a:stretch>
+        </p:blipFill>
+        <p:spPr>
+          <a:xfrm>
+            <a:off x="1864253" y="1463040"/>
+            <a:ext cx="8463188" cy="4709160"/>
+          </a:xfrm>
+          <a:prstGeom prst="rect">
+            <a:avLst/>
+          </a:prstGeom>
+          <a:ln w="12700">
+            <a:solidFill>
+              <a:srgbClr val="C8C8C8"/>
+            </a:solidFill>
+          </a:ln>
+        </p:spPr>
+      </p:pic>
+      <p:sp>
+        <p:nvSpPr>
+          <p:cNvPr id="5" name="TextBox 4"/>
+          <p:cNvSpPr txBox="1"/>
+          <p:nvPr/>
+        </p:nvSpPr>
+        <p:spPr>
+          <a:xfrm>
+            <a:off x="822960" y="6355080"/>
+            <a:ext cx="10515600" cy="411480"/>
+          </a:xfrm>
+          <a:prstGeom prst="rect">
+            <a:avLst/>
+          </a:prstGeom>
+          <a:noFill/>
+        </p:spPr>
+        <p:txBody>
+          <a:bodyPr wrap="square">
+            <a:spAutoFit/>
+          </a:bodyPr>
+          <a:lstStyle/>
+          <a:p>
+            <a:r>
+              <a:rPr sz="1400" i="1">
+                <a:solidFill>
+                  <a:srgbClr val="595959"/>
+                </a:solidFill>
+                <a:latin typeface="Calibri"/>
+              </a:rPr>
+              <a:t>One practice at a time — and a partner expecting you at the end of week one.</a:t>
+            </a:r>
+          </a:p>
+        </p:txBody>
+      </p:sp>
+      <p:sp>
+        <p:nvSpPr>
+          <p:cNvPr id="90" name="SlideNum"/>
+          <p:cNvSpPr txBox="1"/>
+          <p:nvPr/>
+        </p:nvSpPr>
+        <p:spPr>
+          <a:xfrm>
+            <a:off x="11384280" y="6446520"/>
+            <a:ext cx="640080" cy="292608"/>
+          </a:xfrm>
+          <a:prstGeom prst="rect">
+            <a:avLst/>
+          </a:prstGeom>
+          <a:noFill/>
+        </p:spPr>
+        <p:txBody>
+          <a:bodyPr wrap="none" lIns="0" tIns="0" rIns="45720" bIns="0" anchor="ctr"/>
+          <a:lstStyle/>
+          <a:p>
+            <a:pPr algn="r"/>
+            <a:r>
+              <a:t>135a</a:t>
+            </a:r>
+            <a:endParaRPr sz="1000" b="1">
+              <a:solidFill>
+                <a:srgbClr val="7A8A6E"/>
+              </a:solidFill>
+              <a:latin typeface="Calibri"/>
+            </a:endParaRPr>
+          </a:p>
+        </p:txBody>
+      </p:sp>
+    </p:spTree>
+  </p:cSld>
+  <p:clrMapOvr>
+    <a:masterClrMapping/>
+  </p:clrMapOvr>
+</p:sld>
+</file>
+
+<file path=ppt/slides/slide14.xml><?xml version="1.0" encoding="utf-8"?>
 <p:sld xmlns:a="http://schemas.openxmlformats.org/drawingml/2006/main" xmlns:r="http://schemas.openxmlformats.org/officeDocument/2006/relationships" xmlns:p="http://schemas.openxmlformats.org/presentationml/2006/main">
   <p:cSld>
     <p:spTree>
@@ -5416,7 +6072,7 @@
 </p:sld>
 </file>
 
-<file path=ppt/slides/slide13.xml><?xml version="1.0" encoding="utf-8"?>
+<file path=ppt/slides/slide15.xml><?xml version="1.0" encoding="utf-8"?>
 <p:sld xmlns:a="http://schemas.openxmlformats.org/drawingml/2006/main" xmlns:r="http://schemas.openxmlformats.org/officeDocument/2006/relationships" xmlns:p="http://schemas.openxmlformats.org/presentationml/2006/main">
   <p:cSld>
     <p:spTree>
@@ -5807,595 +6463,6 @@
             <a:pPr algn="r"/>
             <a:r>
               <a:t>137</a:t>
-            </a:r>
-            <a:endParaRPr sz="1000" b="1">
-              <a:solidFill>
-                <a:srgbClr val="7A8A6E"/>
-              </a:solidFill>
-              <a:latin typeface="Calibri"/>
-            </a:endParaRPr>
-          </a:p>
-        </p:txBody>
-      </p:sp>
-    </p:spTree>
-  </p:cSld>
-  <p:clrMapOvr>
-    <a:masterClrMapping/>
-  </p:clrMapOvr>
-</p:sld>
-</file>
-
-<file path=ppt/slides/slide14.xml><?xml version="1.0" encoding="utf-8"?>
-<p:sld xmlns:a="http://schemas.openxmlformats.org/drawingml/2006/main" xmlns:p="http://schemas.openxmlformats.org/presentationml/2006/main" xmlns:r="http://schemas.openxmlformats.org/officeDocument/2006/relationships">
-  <p:cSld>
-    <p:spTree>
-      <p:nvGrpSpPr>
-        <p:cNvPr id="1" name=""/>
-        <p:cNvGrpSpPr/>
-        <p:nvPr/>
-      </p:nvGrpSpPr>
-      <p:grpSpPr/>
-      <p:sp>
-        <p:nvSpPr>
-          <p:cNvPr id="2" name="Rectangle 1"/>
-          <p:cNvSpPr/>
-          <p:nvPr/>
-        </p:nvSpPr>
-        <p:spPr>
-          <a:xfrm>
-            <a:off x="0" y="0"/>
-            <a:ext cx="12192000" cy="6858000"/>
-          </a:xfrm>
-          <a:prstGeom prst="rect">
-            <a:avLst/>
-          </a:prstGeom>
-          <a:solidFill>
-            <a:srgbClr val="FFFFFF"/>
-          </a:solidFill>
-          <a:ln>
-            <a:noFill/>
-          </a:ln>
-          <a:effectLst/>
-        </p:spPr>
-        <p:style>
-          <a:lnRef idx="1">
-            <a:schemeClr val="accent1"/>
-          </a:lnRef>
-          <a:fillRef idx="3">
-            <a:schemeClr val="accent1"/>
-          </a:fillRef>
-          <a:effectRef idx="2">
-            <a:schemeClr val="accent1"/>
-          </a:effectRef>
-          <a:fontRef idx="minor">
-            <a:schemeClr val="lt1"/>
-          </a:fontRef>
-        </p:style>
-        <p:txBody>
-          <a:bodyPr rtlCol="0" anchor="ctr"/>
-          <a:lstStyle/>
-          <a:p>
-            <a:pPr algn="ctr"/>
-          </a:p>
-        </p:txBody>
-      </p:sp>
-      <p:sp>
-        <p:nvSpPr>
-          <p:cNvPr id="3" name="TextBox 2"/>
-          <p:cNvSpPr txBox="1"/>
-          <p:nvPr/>
-        </p:nvSpPr>
-        <p:spPr>
-          <a:xfrm>
-            <a:off x="822960" y="502920"/>
-            <a:ext cx="10515600" cy="822960"/>
-          </a:xfrm>
-          <a:prstGeom prst="rect">
-            <a:avLst/>
-          </a:prstGeom>
-          <a:noFill/>
-        </p:spPr>
-        <p:txBody>
-          <a:bodyPr wrap="square">
-            <a:spAutoFit/>
-          </a:bodyPr>
-          <a:lstStyle/>
-          <a:p>
-            <a:r>
-              <a:rPr sz="2800" b="1">
-                <a:solidFill>
-                  <a:srgbClr val="2C5F2D"/>
-                </a:solidFill>
-                <a:latin typeface="Cambria"/>
-              </a:rPr>
-              <a:t>Where We Are — the Four Connects</a:t>
-            </a:r>
-          </a:p>
-        </p:txBody>
-      </p:sp>
-      <p:pic>
-        <p:nvPicPr>
-          <p:cNvPr id="4" name="Picture 3" descr="four-connects.png"/>
-          <p:cNvPicPr>
-            <a:picLocks noChangeAspect="1"/>
-          </p:cNvPicPr>
-          <p:nvPr/>
-        </p:nvPicPr>
-        <p:blipFill>
-          <a:blip r:embed="rId2"/>
-          <a:stretch>
-            <a:fillRect/>
-          </a:stretch>
-        </p:blipFill>
-        <p:spPr>
-          <a:xfrm>
-            <a:off x="932688" y="1645920"/>
-            <a:ext cx="10332720" cy="3708663"/>
-          </a:xfrm>
-          <a:prstGeom prst="rect">
-            <a:avLst/>
-          </a:prstGeom>
-        </p:spPr>
-      </p:pic>
-      <p:sp>
-        <p:nvSpPr>
-          <p:cNvPr id="5" name="TextBox 4"/>
-          <p:cNvSpPr txBox="1"/>
-          <p:nvPr/>
-        </p:nvSpPr>
-        <p:spPr>
-          <a:xfrm>
-            <a:off x="822960" y="5623560"/>
-            <a:ext cx="10515600" cy="914400"/>
-          </a:xfrm>
-          <a:prstGeom prst="rect">
-            <a:avLst/>
-          </a:prstGeom>
-          <a:noFill/>
-        </p:spPr>
-        <p:txBody>
-          <a:bodyPr wrap="square">
-            <a:spAutoFit/>
-          </a:bodyPr>
-          <a:lstStyle/>
-          <a:p>
-            <a:r>
-              <a:rPr sz="1800" b="0">
-                <a:solidFill>
-                  <a:srgbClr val="222B22"/>
-                </a:solidFill>
-                <a:latin typeface="Calibri"/>
-              </a:rPr>
-              <a:t>Session 10 stands in the third box — </a:t>
-            </a:r>
-            <a:r>
-              <a:rPr sz="1800" b="1">
-                <a:solidFill>
-                  <a:srgbClr val="2C5F2D"/>
-                </a:solidFill>
-                <a:latin typeface="Calibri"/>
-              </a:rPr>
-              <a:t>Connect with God</a:t>
-            </a:r>
-            <a:r>
-              <a:rPr sz="1800" b="0">
-                <a:solidFill>
-                  <a:srgbClr val="222B22"/>
-                </a:solidFill>
-                <a:latin typeface="Calibri"/>
-              </a:rPr>
-              <a:t> — walked again, teen-led. Each connection makes the next one real (Matt. 22:37–40).</a:t>
-            </a:r>
-          </a:p>
-        </p:txBody>
-      </p:sp>
-      <p:sp>
-        <p:nvSpPr>
-          <p:cNvPr id="90" name="SlideNum"/>
-          <p:cNvSpPr txBox="1"/>
-          <p:nvPr/>
-        </p:nvSpPr>
-        <p:spPr>
-          <a:xfrm>
-            <a:off x="11384280" y="6446520"/>
-            <a:ext cx="640080" cy="292608"/>
-          </a:xfrm>
-          <a:prstGeom prst="rect">
-            <a:avLst/>
-          </a:prstGeom>
-          <a:noFill/>
-        </p:spPr>
-        <p:txBody>
-          <a:bodyPr wrap="none" lIns="0" tIns="0" rIns="45720" bIns="0" anchor="ctr"/>
-          <a:lstStyle/>
-          <a:p>
-            <a:pPr algn="r"/>
-            <a:r>
-              <a:t>126a</a:t>
-            </a:r>
-            <a:endParaRPr sz="1000" b="1">
-              <a:solidFill>
-                <a:srgbClr val="7A8A6E"/>
-              </a:solidFill>
-              <a:latin typeface="Calibri"/>
-            </a:endParaRPr>
-          </a:p>
-        </p:txBody>
-      </p:sp>
-    </p:spTree>
-  </p:cSld>
-  <p:clrMapOvr>
-    <a:masterClrMapping/>
-  </p:clrMapOvr>
-</p:sld>
-</file>
-
-<file path=ppt/slides/slide15.xml><?xml version="1.0" encoding="utf-8"?>
-<p:sld xmlns:a="http://schemas.openxmlformats.org/drawingml/2006/main" xmlns:p="http://schemas.openxmlformats.org/presentationml/2006/main" xmlns:r="http://schemas.openxmlformats.org/officeDocument/2006/relationships">
-  <p:cSld>
-    <p:spTree>
-      <p:nvGrpSpPr>
-        <p:cNvPr id="1" name=""/>
-        <p:cNvGrpSpPr/>
-        <p:nvPr/>
-      </p:nvGrpSpPr>
-      <p:grpSpPr/>
-      <p:sp>
-        <p:nvSpPr>
-          <p:cNvPr id="2" name="Rectangle 1"/>
-          <p:cNvSpPr/>
-          <p:nvPr/>
-        </p:nvSpPr>
-        <p:spPr>
-          <a:xfrm>
-            <a:off x="0" y="0"/>
-            <a:ext cx="12192000" cy="6858000"/>
-          </a:xfrm>
-          <a:prstGeom prst="rect">
-            <a:avLst/>
-          </a:prstGeom>
-          <a:solidFill>
-            <a:srgbClr val="FFFFFF"/>
-          </a:solidFill>
-          <a:ln>
-            <a:noFill/>
-          </a:ln>
-          <a:effectLst/>
-        </p:spPr>
-        <p:style>
-          <a:lnRef idx="1">
-            <a:schemeClr val="accent1"/>
-          </a:lnRef>
-          <a:fillRef idx="3">
-            <a:schemeClr val="accent1"/>
-          </a:fillRef>
-          <a:effectRef idx="2">
-            <a:schemeClr val="accent1"/>
-          </a:effectRef>
-          <a:fontRef idx="minor">
-            <a:schemeClr val="lt1"/>
-          </a:fontRef>
-        </p:style>
-        <p:txBody>
-          <a:bodyPr rtlCol="0" anchor="ctr"/>
-          <a:lstStyle/>
-          <a:p>
-            <a:pPr algn="ctr"/>
-          </a:p>
-        </p:txBody>
-      </p:sp>
-      <p:sp>
-        <p:nvSpPr>
-          <p:cNvPr id="3" name="TextBox 2"/>
-          <p:cNvSpPr txBox="1"/>
-          <p:nvPr/>
-        </p:nvSpPr>
-        <p:spPr>
-          <a:xfrm>
-            <a:off x="822960" y="502920"/>
-            <a:ext cx="10515600" cy="822960"/>
-          </a:xfrm>
-          <a:prstGeom prst="rect">
-            <a:avLst/>
-          </a:prstGeom>
-          <a:noFill/>
-        </p:spPr>
-        <p:txBody>
-          <a:bodyPr wrap="square">
-            <a:spAutoFit/>
-          </a:bodyPr>
-          <a:lstStyle/>
-          <a:p>
-            <a:r>
-              <a:rPr sz="2800" b="1">
-                <a:solidFill>
-                  <a:srgbClr val="2C5F2D"/>
-                </a:solidFill>
-                <a:latin typeface="Cambria"/>
-              </a:rPr>
-              <a:t>The Take-Home Sheet — the Daily Rhythm</a:t>
-            </a:r>
-          </a:p>
-        </p:txBody>
-      </p:sp>
-      <p:pic>
-        <p:nvPicPr>
-          <p:cNvPr id="4" name="Picture 3" descr="s10_part1.png"/>
-          <p:cNvPicPr>
-            <a:picLocks noChangeAspect="1"/>
-          </p:cNvPicPr>
-          <p:nvPr/>
-        </p:nvPicPr>
-        <p:blipFill>
-          <a:blip r:embed="rId2"/>
-          <a:stretch>
-            <a:fillRect/>
-          </a:stretch>
-        </p:blipFill>
-        <p:spPr>
-          <a:xfrm>
-            <a:off x="1798167" y="1463040"/>
-            <a:ext cx="8595360" cy="4457308"/>
-          </a:xfrm>
-          <a:prstGeom prst="rect">
-            <a:avLst/>
-          </a:prstGeom>
-          <a:ln w="12700">
-            <a:solidFill>
-              <a:srgbClr val="C8C8C8"/>
-            </a:solidFill>
-          </a:ln>
-        </p:spPr>
-      </p:pic>
-      <p:sp>
-        <p:nvSpPr>
-          <p:cNvPr id="5" name="TextBox 4"/>
-          <p:cNvSpPr txBox="1"/>
-          <p:nvPr/>
-        </p:nvSpPr>
-        <p:spPr>
-          <a:xfrm>
-            <a:off x="822960" y="6355080"/>
-            <a:ext cx="10515600" cy="411480"/>
-          </a:xfrm>
-          <a:prstGeom prst="rect">
-            <a:avLst/>
-          </a:prstGeom>
-          <a:noFill/>
-        </p:spPr>
-        <p:txBody>
-          <a:bodyPr wrap="square">
-            <a:spAutoFit/>
-          </a:bodyPr>
-          <a:lstStyle/>
-          <a:p>
-            <a:r>
-              <a:rPr sz="1400" i="1">
-                <a:solidFill>
-                  <a:srgbClr val="595959"/>
-                </a:solidFill>
-                <a:latin typeface="Calibri"/>
-              </a:rPr>
-              <a:t>Handed out now — this is the sheet in your hands.</a:t>
-            </a:r>
-          </a:p>
-        </p:txBody>
-      </p:sp>
-      <p:sp>
-        <p:nvSpPr>
-          <p:cNvPr id="90" name="SlideNum"/>
-          <p:cNvSpPr txBox="1"/>
-          <p:nvPr/>
-        </p:nvSpPr>
-        <p:spPr>
-          <a:xfrm>
-            <a:off x="11384280" y="6446520"/>
-            <a:ext cx="640080" cy="292608"/>
-          </a:xfrm>
-          <a:prstGeom prst="rect">
-            <a:avLst/>
-          </a:prstGeom>
-          <a:noFill/>
-        </p:spPr>
-        <p:txBody>
-          <a:bodyPr wrap="none" lIns="0" tIns="0" rIns="45720" bIns="0" anchor="ctr"/>
-          <a:lstStyle/>
-          <a:p>
-            <a:pPr algn="r"/>
-            <a:r>
-              <a:t>135</a:t>
-            </a:r>
-            <a:endParaRPr sz="1000" b="1">
-              <a:solidFill>
-                <a:srgbClr val="7A8A6E"/>
-              </a:solidFill>
-              <a:latin typeface="Calibri"/>
-            </a:endParaRPr>
-          </a:p>
-        </p:txBody>
-      </p:sp>
-    </p:spTree>
-  </p:cSld>
-  <p:clrMapOvr>
-    <a:masterClrMapping/>
-  </p:clrMapOvr>
-</p:sld>
-</file>
-
-<file path=ppt/slides/slide16.xml><?xml version="1.0" encoding="utf-8"?>
-<p:sld xmlns:a="http://schemas.openxmlformats.org/drawingml/2006/main" xmlns:p="http://schemas.openxmlformats.org/presentationml/2006/main" xmlns:r="http://schemas.openxmlformats.org/officeDocument/2006/relationships">
-  <p:cSld>
-    <p:spTree>
-      <p:nvGrpSpPr>
-        <p:cNvPr id="1" name=""/>
-        <p:cNvGrpSpPr/>
-        <p:nvPr/>
-      </p:nvGrpSpPr>
-      <p:grpSpPr/>
-      <p:sp>
-        <p:nvSpPr>
-          <p:cNvPr id="2" name="Rectangle 1"/>
-          <p:cNvSpPr/>
-          <p:nvPr/>
-        </p:nvSpPr>
-        <p:spPr>
-          <a:xfrm>
-            <a:off x="0" y="0"/>
-            <a:ext cx="12192000" cy="6858000"/>
-          </a:xfrm>
-          <a:prstGeom prst="rect">
-            <a:avLst/>
-          </a:prstGeom>
-          <a:solidFill>
-            <a:srgbClr val="FFFFFF"/>
-          </a:solidFill>
-          <a:ln>
-            <a:noFill/>
-          </a:ln>
-          <a:effectLst/>
-        </p:spPr>
-        <p:style>
-          <a:lnRef idx="1">
-            <a:schemeClr val="accent1"/>
-          </a:lnRef>
-          <a:fillRef idx="3">
-            <a:schemeClr val="accent1"/>
-          </a:fillRef>
-          <a:effectRef idx="2">
-            <a:schemeClr val="accent1"/>
-          </a:effectRef>
-          <a:fontRef idx="minor">
-            <a:schemeClr val="lt1"/>
-          </a:fontRef>
-        </p:style>
-        <p:txBody>
-          <a:bodyPr rtlCol="0" anchor="ctr"/>
-          <a:lstStyle/>
-          <a:p>
-            <a:pPr algn="ctr"/>
-          </a:p>
-        </p:txBody>
-      </p:sp>
-      <p:sp>
-        <p:nvSpPr>
-          <p:cNvPr id="3" name="TextBox 2"/>
-          <p:cNvSpPr txBox="1"/>
-          <p:nvPr/>
-        </p:nvSpPr>
-        <p:spPr>
-          <a:xfrm>
-            <a:off x="822960" y="502920"/>
-            <a:ext cx="10515600" cy="822960"/>
-          </a:xfrm>
-          <a:prstGeom prst="rect">
-            <a:avLst/>
-          </a:prstGeom>
-          <a:noFill/>
-        </p:spPr>
-        <p:txBody>
-          <a:bodyPr wrap="square">
-            <a:spAutoFit/>
-          </a:bodyPr>
-          <a:lstStyle/>
-          <a:p>
-            <a:r>
-              <a:rPr sz="2800" b="1">
-                <a:solidFill>
-                  <a:srgbClr val="2C5F2D"/>
-                </a:solidFill>
-                <a:latin typeface="Cambria"/>
-              </a:rPr>
-              <a:t>The Take-Home Sheet — the Four Parts</a:t>
-            </a:r>
-          </a:p>
-        </p:txBody>
-      </p:sp>
-      <p:pic>
-        <p:nvPicPr>
-          <p:cNvPr id="4" name="Picture 3" descr="s10_part2.png"/>
-          <p:cNvPicPr>
-            <a:picLocks noChangeAspect="1"/>
-          </p:cNvPicPr>
-          <p:nvPr/>
-        </p:nvPicPr>
-        <p:blipFill>
-          <a:blip r:embed="rId2"/>
-          <a:stretch>
-            <a:fillRect/>
-          </a:stretch>
-        </p:blipFill>
-        <p:spPr>
-          <a:xfrm>
-            <a:off x="1864253" y="1463040"/>
-            <a:ext cx="8463188" cy="4709160"/>
-          </a:xfrm>
-          <a:prstGeom prst="rect">
-            <a:avLst/>
-          </a:prstGeom>
-          <a:ln w="12700">
-            <a:solidFill>
-              <a:srgbClr val="C8C8C8"/>
-            </a:solidFill>
-          </a:ln>
-        </p:spPr>
-      </p:pic>
-      <p:sp>
-        <p:nvSpPr>
-          <p:cNvPr id="5" name="TextBox 4"/>
-          <p:cNvSpPr txBox="1"/>
-          <p:nvPr/>
-        </p:nvSpPr>
-        <p:spPr>
-          <a:xfrm>
-            <a:off x="822960" y="6355080"/>
-            <a:ext cx="10515600" cy="411480"/>
-          </a:xfrm>
-          <a:prstGeom prst="rect">
-            <a:avLst/>
-          </a:prstGeom>
-          <a:noFill/>
-        </p:spPr>
-        <p:txBody>
-          <a:bodyPr wrap="square">
-            <a:spAutoFit/>
-          </a:bodyPr>
-          <a:lstStyle/>
-          <a:p>
-            <a:r>
-              <a:rPr sz="1400" i="1">
-                <a:solidFill>
-                  <a:srgbClr val="595959"/>
-                </a:solidFill>
-                <a:latin typeface="Calibri"/>
-              </a:rPr>
-              <a:t>One practice at a time — and a partner expecting you at the end of week one.</a:t>
-            </a:r>
-          </a:p>
-        </p:txBody>
-      </p:sp>
-      <p:sp>
-        <p:nvSpPr>
-          <p:cNvPr id="90" name="SlideNum"/>
-          <p:cNvSpPr txBox="1"/>
-          <p:nvPr/>
-        </p:nvSpPr>
-        <p:spPr>
-          <a:xfrm>
-            <a:off x="11384280" y="6446520"/>
-            <a:ext cx="640080" cy="292608"/>
-          </a:xfrm>
-          <a:prstGeom prst="rect">
-            <a:avLst/>
-          </a:prstGeom>
-          <a:noFill/>
-        </p:spPr>
-        <p:txBody>
-          <a:bodyPr wrap="none" lIns="0" tIns="0" rIns="45720" bIns="0" anchor="ctr"/>
-          <a:lstStyle/>
-          <a:p>
-            <a:pPr algn="r"/>
-            <a:r>
-              <a:t>135a</a:t>
             </a:r>
             <a:endParaRPr sz="1000" b="1">
               <a:solidFill>
@@ -6664,6 +6731,211 @@
 </file>
 
 <file path=ppt/slides/slide3.xml><?xml version="1.0" encoding="utf-8"?>
+<p:sld xmlns:a="http://schemas.openxmlformats.org/drawingml/2006/main" xmlns:p="http://schemas.openxmlformats.org/presentationml/2006/main" xmlns:r="http://schemas.openxmlformats.org/officeDocument/2006/relationships">
+  <p:cSld>
+    <p:spTree>
+      <p:nvGrpSpPr>
+        <p:cNvPr id="1" name=""/>
+        <p:cNvGrpSpPr/>
+        <p:nvPr/>
+      </p:nvGrpSpPr>
+      <p:grpSpPr/>
+      <p:sp>
+        <p:nvSpPr>
+          <p:cNvPr id="2" name="Rectangle 1"/>
+          <p:cNvSpPr/>
+          <p:nvPr/>
+        </p:nvSpPr>
+        <p:spPr>
+          <a:xfrm>
+            <a:off x="0" y="0"/>
+            <a:ext cx="12192000" cy="6858000"/>
+          </a:xfrm>
+          <a:prstGeom prst="rect">
+            <a:avLst/>
+          </a:prstGeom>
+          <a:solidFill>
+            <a:srgbClr val="FFFFFF"/>
+          </a:solidFill>
+          <a:ln>
+            <a:noFill/>
+          </a:ln>
+          <a:effectLst/>
+        </p:spPr>
+        <p:style>
+          <a:lnRef idx="1">
+            <a:schemeClr val="accent1"/>
+          </a:lnRef>
+          <a:fillRef idx="3">
+            <a:schemeClr val="accent1"/>
+          </a:fillRef>
+          <a:effectRef idx="2">
+            <a:schemeClr val="accent1"/>
+          </a:effectRef>
+          <a:fontRef idx="minor">
+            <a:schemeClr val="lt1"/>
+          </a:fontRef>
+        </p:style>
+        <p:txBody>
+          <a:bodyPr rtlCol="0" anchor="ctr"/>
+          <a:lstStyle/>
+          <a:p>
+            <a:pPr algn="ctr"/>
+          </a:p>
+        </p:txBody>
+      </p:sp>
+      <p:sp>
+        <p:nvSpPr>
+          <p:cNvPr id="3" name="TextBox 2"/>
+          <p:cNvSpPr txBox="1"/>
+          <p:nvPr/>
+        </p:nvSpPr>
+        <p:spPr>
+          <a:xfrm>
+            <a:off x="822960" y="502920"/>
+            <a:ext cx="10515600" cy="822960"/>
+          </a:xfrm>
+          <a:prstGeom prst="rect">
+            <a:avLst/>
+          </a:prstGeom>
+          <a:noFill/>
+        </p:spPr>
+        <p:txBody>
+          <a:bodyPr wrap="square">
+            <a:spAutoFit/>
+          </a:bodyPr>
+          <a:lstStyle/>
+          <a:p>
+            <a:r>
+              <a:rPr sz="2800" b="1">
+                <a:solidFill>
+                  <a:srgbClr val="2C5F2D"/>
+                </a:solidFill>
+                <a:latin typeface="Cambria"/>
+              </a:rPr>
+              <a:t>Where We Are — the Four Connects</a:t>
+            </a:r>
+          </a:p>
+        </p:txBody>
+      </p:sp>
+      <p:sp>
+        <p:nvSpPr>
+          <p:cNvPr id="5" name="TextBox 4"/>
+          <p:cNvSpPr txBox="1"/>
+          <p:nvPr/>
+        </p:nvSpPr>
+        <p:spPr>
+          <a:xfrm>
+            <a:off x="822960" y="5623560"/>
+            <a:ext cx="10515600" cy="914400"/>
+          </a:xfrm>
+          <a:prstGeom prst="rect">
+            <a:avLst/>
+          </a:prstGeom>
+          <a:noFill/>
+        </p:spPr>
+        <p:txBody>
+          <a:bodyPr wrap="square">
+            <a:spAutoFit/>
+          </a:bodyPr>
+          <a:lstStyle/>
+          <a:p>
+            <a:r>
+              <a:rPr sz="1800" b="0">
+                <a:solidFill>
+                  <a:srgbClr val="222B22"/>
+                </a:solidFill>
+                <a:latin typeface="Calibri"/>
+              </a:rPr>
+              <a:t>Session 10 stands in the third box — </a:t>
+            </a:r>
+            <a:r>
+              <a:rPr sz="1800" b="1">
+                <a:solidFill>
+                  <a:srgbClr val="2C5F2D"/>
+                </a:solidFill>
+                <a:latin typeface="Calibri"/>
+              </a:rPr>
+              <a:t>Connect with God</a:t>
+            </a:r>
+            <a:r>
+              <a:rPr sz="1800" b="0">
+                <a:solidFill>
+                  <a:srgbClr val="222B22"/>
+                </a:solidFill>
+                <a:latin typeface="Calibri"/>
+              </a:rPr>
+              <a:t> — walked again, teen-led. Each connection makes the next one real (Matt. 22:37–40).</a:t>
+            </a:r>
+          </a:p>
+        </p:txBody>
+      </p:sp>
+      <p:sp>
+        <p:nvSpPr>
+          <p:cNvPr id="90" name="SlideNum"/>
+          <p:cNvSpPr txBox="1"/>
+          <p:nvPr/>
+        </p:nvSpPr>
+        <p:spPr>
+          <a:xfrm>
+            <a:off x="11384280" y="6446520"/>
+            <a:ext cx="640080" cy="292608"/>
+          </a:xfrm>
+          <a:prstGeom prst="rect">
+            <a:avLst/>
+          </a:prstGeom>
+          <a:noFill/>
+        </p:spPr>
+        <p:txBody>
+          <a:bodyPr wrap="none" lIns="0" tIns="0" rIns="45720" bIns="0" anchor="ctr"/>
+          <a:lstStyle/>
+          <a:p>
+            <a:pPr algn="r"/>
+            <a:r>
+              <a:t>126a</a:t>
+            </a:r>
+            <a:endParaRPr sz="1000" b="1">
+              <a:solidFill>
+                <a:srgbClr val="7A8A6E"/>
+              </a:solidFill>
+              <a:latin typeface="Calibri"/>
+            </a:endParaRPr>
+          </a:p>
+        </p:txBody>
+      </p:sp>
+      <p:pic>
+        <p:nvPicPr>
+          <p:cNvPr id="91" name="Picture 90" descr="four-connects.png"/>
+          <p:cNvPicPr>
+            <a:picLocks noChangeAspect="1"/>
+          </p:cNvPicPr>
+          <p:nvPr/>
+        </p:nvPicPr>
+        <p:blipFill>
+          <a:blip r:embed="rId4"/>
+          <a:stretch>
+            <a:fillRect/>
+          </a:stretch>
+        </p:blipFill>
+        <p:spPr>
+          <a:xfrm>
+            <a:off x="932688" y="1645920"/>
+            <a:ext cx="10332720" cy="3708663"/>
+          </a:xfrm>
+          <a:prstGeom prst="rect">
+            <a:avLst/>
+          </a:prstGeom>
+        </p:spPr>
+      </p:pic>
+    </p:spTree>
+  </p:cSld>
+  <p:clrMapOvr>
+    <a:masterClrMapping/>
+  </p:clrMapOvr>
+</p:sld>
+</file>
+
+<file path=ppt/slides/slide4.xml><?xml version="1.0" encoding="utf-8"?>
 <p:sld xmlns:a="http://schemas.openxmlformats.org/drawingml/2006/main" xmlns:r="http://schemas.openxmlformats.org/officeDocument/2006/relationships" xmlns:p="http://schemas.openxmlformats.org/presentationml/2006/main">
   <p:cSld>
     <p:spTree>
@@ -7089,7 +7361,7 @@
 </p:sld>
 </file>
 
-<file path=ppt/slides/slide4.xml><?xml version="1.0" encoding="utf-8"?>
+<file path=ppt/slides/slide5.xml><?xml version="1.0" encoding="utf-8"?>
 <p:sld xmlns:a="http://schemas.openxmlformats.org/drawingml/2006/main" xmlns:r="http://schemas.openxmlformats.org/officeDocument/2006/relationships" xmlns:p="http://schemas.openxmlformats.org/presentationml/2006/main">
   <p:cSld>
     <p:spTree>
@@ -7436,7 +7708,7 @@
 </p:sld>
 </file>
 
-<file path=ppt/slides/slide5.xml><?xml version="1.0" encoding="utf-8"?>
+<file path=ppt/slides/slide6.xml><?xml version="1.0" encoding="utf-8"?>
 <p:sld xmlns:a="http://schemas.openxmlformats.org/drawingml/2006/main" xmlns:r="http://schemas.openxmlformats.org/officeDocument/2006/relationships" xmlns:p="http://schemas.openxmlformats.org/presentationml/2006/main">
   <p:cSld>
     <p:spTree>
@@ -7719,333 +7991,6 @@
 </p:sld>
 </file>
 
-<file path=ppt/slides/slide6.xml><?xml version="1.0" encoding="utf-8"?>
-<p:sld xmlns:a="http://schemas.openxmlformats.org/drawingml/2006/main" xmlns:r="http://schemas.openxmlformats.org/officeDocument/2006/relationships" xmlns:p="http://schemas.openxmlformats.org/presentationml/2006/main">
-  <p:cSld>
-    <p:spTree>
-      <p:nvGrpSpPr>
-        <p:cNvPr id="1" name=""/>
-        <p:cNvGrpSpPr/>
-        <p:nvPr/>
-      </p:nvGrpSpPr>
-      <p:grpSpPr>
-        <a:xfrm>
-          <a:off x="0" y="0"/>
-          <a:ext cx="0" cy="0"/>
-          <a:chOff x="0" y="0"/>
-          <a:chExt cx="0" cy="0"/>
-        </a:xfrm>
-      </p:grpSpPr>
-      <p:sp>
-        <p:nvSpPr>
-          <p:cNvPr id="2" name="Rectangle 1"/>
-          <p:cNvSpPr/>
-          <p:nvPr/>
-        </p:nvSpPr>
-        <p:spPr>
-          <a:xfrm>
-            <a:off x="0" y="0"/>
-            <a:ext cx="12191695" cy="6858000"/>
-          </a:xfrm>
-          <a:prstGeom prst="rect">
-            <a:avLst/>
-          </a:prstGeom>
-          <a:solidFill>
-            <a:srgbClr val="FFFFFF"/>
-          </a:solidFill>
-          <a:ln>
-            <a:noFill/>
-          </a:ln>
-        </p:spPr>
-        <p:txBody>
-          <a:bodyPr/>
-          <a:lstStyle/>
-          <a:p>
-            <a:endParaRPr/>
-          </a:p>
-        </p:txBody>
-      </p:sp>
-      <p:sp>
-        <p:nvSpPr>
-          <p:cNvPr id="3" name="TextBox 2"/>
-          <p:cNvSpPr txBox="1"/>
-          <p:nvPr/>
-        </p:nvSpPr>
-        <p:spPr>
-          <a:xfrm>
-            <a:off x="822960" y="502920"/>
-            <a:ext cx="10515600" cy="822960"/>
-          </a:xfrm>
-          <a:prstGeom prst="rect">
-            <a:avLst/>
-          </a:prstGeom>
-          <a:noFill/>
-        </p:spPr>
-        <p:txBody>
-          <a:bodyPr wrap="square">
-            <a:spAutoFit/>
-          </a:bodyPr>
-          <a:lstStyle/>
-          <a:p>
-            <a:pPr algn="l">
-              <a:spcAft>
-                <a:spcPts val="600"/>
-              </a:spcAft>
-            </a:pPr>
-            <a:r>
-              <a:rPr sz="2800" b="1" i="0">
-                <a:solidFill>
-                  <a:srgbClr val="2C5F2D"/>
-                </a:solidFill>
-                <a:latin typeface="Cambria"/>
-              </a:rPr>
-              <a:t>Scripture and Brief Re-Framing</a:t>
-            </a:r>
-          </a:p>
-        </p:txBody>
-      </p:sp>
-      <p:sp>
-        <p:nvSpPr>
-          <p:cNvPr id="4" name="TextBox 4"/>
-          <p:cNvSpPr txBox="1"/>
-          <p:nvPr/>
-        </p:nvSpPr>
-        <p:spPr>
-          <a:xfrm>
-            <a:off x="822960" y="1600200"/>
-            <a:ext cx="5669280" cy="4572000"/>
-          </a:xfrm>
-          <a:prstGeom prst="rect">
-            <a:avLst/>
-          </a:prstGeom>
-          <a:noFill/>
-        </p:spPr>
-        <p:txBody>
-          <a:bodyPr wrap="square" lIns="91440" tIns="91440" rIns="91440" bIns="91440"/>
-          <a:lstStyle/>
-          <a:p>
-            <a:pPr marL="274320" indent="-274320">
-              <a:spcAft>
-                <a:spcPts val="800"/>
-              </a:spcAft>
-            </a:pPr>
-            <a:r>
-              <a:rPr sz="2000" b="1" i="0">
-                <a:solidFill>
-                  <a:srgbClr val="97BC62"/>
-                </a:solidFill>
-                <a:latin typeface="Calibri"/>
-              </a:rPr>
-              <a:t>•  </a:t>
-            </a:r>
-            <a:r>
-              <a:rPr sz="2000" b="0" i="0">
-                <a:solidFill>
-                  <a:srgbClr val="222B22"/>
-                </a:solidFill>
-                <a:latin typeface="Calibri"/>
-              </a:rPr>
-              <a:t>Same two anchors as last week — Psalm 23 and John 15:1–11 — “Listen as if for the first time anyway.”</a:t>
-            </a:r>
-          </a:p>
-          <a:p>
-            <a:pPr marL="274320" indent="-274320">
-              <a:spcAft>
-                <a:spcPts val="800"/>
-              </a:spcAft>
-            </a:pPr>
-            <a:r>
-              <a:rPr sz="2000" b="1" i="0">
-                <a:solidFill>
-                  <a:srgbClr val="97BC62"/>
-                </a:solidFill>
-                <a:latin typeface="Calibri"/>
-              </a:rPr>
-              <a:t>•  </a:t>
-            </a:r>
-            <a:r>
-              <a:rPr sz="2000" b="0" i="0">
-                <a:solidFill>
-                  <a:srgbClr val="222B22"/>
-                </a:solidFill>
-                <a:latin typeface="Calibri"/>
-              </a:rPr>
-              <a:t>A vinedresser does not visit a vine once — abiding is a rhythm, not an event</a:t>
-            </a:r>
-          </a:p>
-          <a:p>
-            <a:pPr marL="274320" indent="-274320">
-              <a:spcAft>
-                <a:spcPts val="800"/>
-              </a:spcAft>
-            </a:pPr>
-            <a:r>
-              <a:rPr sz="2000" b="1" i="0">
-                <a:solidFill>
-                  <a:srgbClr val="97BC62"/>
-                </a:solidFill>
-                <a:latin typeface="Calibri"/>
-              </a:rPr>
-              <a:t>•  </a:t>
-            </a:r>
-            <a:r>
-              <a:rPr sz="2000" b="0" i="0">
-                <a:solidFill>
-                  <a:srgbClr val="222B22"/>
-                </a:solidFill>
-                <a:latin typeface="Calibri"/>
-              </a:rPr>
-              <a:t>Going back changes things — the garden is not a photograph; it is a living place, because your heart is</a:t>
-            </a:r>
-          </a:p>
-          <a:p>
-            <a:pPr marL="274320" indent="-274320">
-              <a:spcAft>
-                <a:spcPts val="800"/>
-              </a:spcAft>
-            </a:pPr>
-            <a:r>
-              <a:rPr sz="2000" b="1" i="0">
-                <a:solidFill>
-                  <a:srgbClr val="97BC62"/>
-                </a:solidFill>
-                <a:latin typeface="Calibri"/>
-              </a:rPr>
-              <a:t>•  </a:t>
-            </a:r>
-            <a:r>
-              <a:rPr sz="2000" b="0" i="0">
-                <a:solidFill>
-                  <a:srgbClr val="222B22"/>
-                </a:solidFill>
-                <a:latin typeface="Calibri"/>
-              </a:rPr>
-              <a:t>A hard garden last week? Going back in tonight is optional — sit and pray instead, fully honored, no explanation owed</a:t>
-            </a:r>
-          </a:p>
-          <a:p>
-            <a:pPr marL="274320" indent="-274320">
-              <a:spcAft>
-                <a:spcPts val="800"/>
-              </a:spcAft>
-            </a:pPr>
-            <a:r>
-              <a:rPr sz="2000" b="1" i="0">
-                <a:solidFill>
-                  <a:srgbClr val="97BC62"/>
-                </a:solidFill>
-                <a:latin typeface="Calibri"/>
-              </a:rPr>
-              <a:t>•  </a:t>
-            </a:r>
-            <a:r>
-              <a:rPr sz="2000" b="0" i="0">
-                <a:solidFill>
-                  <a:srgbClr val="222B22"/>
-                </a:solidFill>
-                <a:latin typeface="Calibri"/>
-              </a:rPr>
-              <a:t>“The words get you to the gate; the silence is where He meets you.”</a:t>
-            </a:r>
-          </a:p>
-        </p:txBody>
-      </p:sp>
-      <p:sp>
-        <p:nvSpPr>
-          <p:cNvPr id="6" name="TextBox 6"/>
-          <p:cNvSpPr txBox="1"/>
-          <p:nvPr/>
-        </p:nvSpPr>
-        <p:spPr>
-          <a:xfrm>
-            <a:off x="6766560" y="1737360"/>
-            <a:ext cx="4663440" cy="2194560"/>
-          </a:xfrm>
-          <a:prstGeom prst="rect">
-            <a:avLst/>
-          </a:prstGeom>
-          <a:solidFill>
-            <a:srgbClr val="F1F6EC"/>
-          </a:solidFill>
-        </p:spPr>
-        <p:txBody>
-          <a:bodyPr wrap="square" lIns="91440" tIns="91440" rIns="91440" bIns="91440" anchor="ctr"/>
-          <a:lstStyle/>
-          <a:p>
-            <a:pPr>
-              <a:spcAft>
-                <a:spcPts val="900"/>
-              </a:spcAft>
-            </a:pPr>
-            <a:r>
-              <a:rPr sz="1200" b="1" i="0">
-                <a:solidFill>
-                  <a:srgbClr val="97BC62"/>
-                </a:solidFill>
-                <a:latin typeface="Calibri"/>
-              </a:rPr>
-              <a:t>PSALM 23:1–3</a:t>
-            </a:r>
-          </a:p>
-          <a:p>
-            <a:pPr>
-              <a:spcAft>
-                <a:spcPts val="600"/>
-              </a:spcAft>
-            </a:pPr>
-            <a:r>
-              <a:rPr sz="2400" b="0" i="1">
-                <a:solidFill>
-                  <a:srgbClr val="222B22"/>
-                </a:solidFill>
-                <a:latin typeface="Cambria"/>
-              </a:rPr>
-              <a:t>“The Lord is my shepherd; I shall not want. He makes me lie down in green pastures. He leads me beside still waters. He restores my soul.”</a:t>
-            </a:r>
-          </a:p>
-        </p:txBody>
-      </p:sp>
-      <p:sp>
-        <p:nvSpPr>
-          <p:cNvPr id="90" name="SlideNum"/>
-          <p:cNvSpPr txBox="1"/>
-          <p:nvPr/>
-        </p:nvSpPr>
-        <p:spPr>
-          <a:xfrm>
-            <a:off x="11384280" y="6446520"/>
-            <a:ext cx="640080" cy="292608"/>
-          </a:xfrm>
-          <a:prstGeom prst="rect">
-            <a:avLst/>
-          </a:prstGeom>
-          <a:noFill/>
-        </p:spPr>
-        <p:txBody>
-          <a:bodyPr wrap="none" lIns="0" tIns="0" rIns="45720" bIns="0" anchor="ctr"/>
-          <a:lstStyle/>
-          <a:p>
-            <a:pPr algn="r"/>
-            <a:r>
-              <a:t>130</a:t>
-            </a:r>
-            <a:endParaRPr sz="1000" b="1">
-              <a:solidFill>
-                <a:srgbClr val="7A8A6E"/>
-              </a:solidFill>
-              <a:latin typeface="Calibri"/>
-            </a:endParaRPr>
-          </a:p>
-        </p:txBody>
-      </p:sp>
-    </p:spTree>
-  </p:cSld>
-  <p:clrMapOvr>
-    <a:masterClrMapping/>
-  </p:clrMapOvr>
-</p:sld>
-</file>
-
 <file path=ppt/slides/slide7.xml><?xml version="1.0" encoding="utf-8"?>
 <p:sld xmlns:a="http://schemas.openxmlformats.org/drawingml/2006/main" xmlns:r="http://schemas.openxmlformats.org/officeDocument/2006/relationships" xmlns:p="http://schemas.openxmlformats.org/presentationml/2006/main">
   <p:cSld>
@@ -8126,6 +8071,333 @@
                 </a:solidFill>
                 <a:latin typeface="Cambria"/>
               </a:rPr>
+              <a:t>Scripture and Brief Re-Framing</a:t>
+            </a:r>
+          </a:p>
+        </p:txBody>
+      </p:sp>
+      <p:sp>
+        <p:nvSpPr>
+          <p:cNvPr id="4" name="TextBox 4"/>
+          <p:cNvSpPr txBox="1"/>
+          <p:nvPr/>
+        </p:nvSpPr>
+        <p:spPr>
+          <a:xfrm>
+            <a:off x="822960" y="1600200"/>
+            <a:ext cx="5669280" cy="4572000"/>
+          </a:xfrm>
+          <a:prstGeom prst="rect">
+            <a:avLst/>
+          </a:prstGeom>
+          <a:noFill/>
+        </p:spPr>
+        <p:txBody>
+          <a:bodyPr wrap="square" lIns="91440" tIns="91440" rIns="91440" bIns="91440"/>
+          <a:lstStyle/>
+          <a:p>
+            <a:pPr marL="274320" indent="-274320">
+              <a:spcAft>
+                <a:spcPts val="800"/>
+              </a:spcAft>
+            </a:pPr>
+            <a:r>
+              <a:rPr sz="2000" b="1" i="0">
+                <a:solidFill>
+                  <a:srgbClr val="97BC62"/>
+                </a:solidFill>
+                <a:latin typeface="Calibri"/>
+              </a:rPr>
+              <a:t>•  </a:t>
+            </a:r>
+            <a:r>
+              <a:rPr sz="2000" b="0" i="0">
+                <a:solidFill>
+                  <a:srgbClr val="222B22"/>
+                </a:solidFill>
+                <a:latin typeface="Calibri"/>
+              </a:rPr>
+              <a:t>Same two anchors as last week — Psalm 23 and John 15:1–11 — “Listen as if for the first time anyway.”</a:t>
+            </a:r>
+          </a:p>
+          <a:p>
+            <a:pPr marL="274320" indent="-274320">
+              <a:spcAft>
+                <a:spcPts val="800"/>
+              </a:spcAft>
+            </a:pPr>
+            <a:r>
+              <a:rPr sz="2000" b="1" i="0">
+                <a:solidFill>
+                  <a:srgbClr val="97BC62"/>
+                </a:solidFill>
+                <a:latin typeface="Calibri"/>
+              </a:rPr>
+              <a:t>•  </a:t>
+            </a:r>
+            <a:r>
+              <a:rPr sz="2000" b="0" i="0">
+                <a:solidFill>
+                  <a:srgbClr val="222B22"/>
+                </a:solidFill>
+                <a:latin typeface="Calibri"/>
+              </a:rPr>
+              <a:t>A vinedresser does not visit a vine once — abiding is a rhythm, not an event</a:t>
+            </a:r>
+          </a:p>
+          <a:p>
+            <a:pPr marL="274320" indent="-274320">
+              <a:spcAft>
+                <a:spcPts val="800"/>
+              </a:spcAft>
+            </a:pPr>
+            <a:r>
+              <a:rPr sz="2000" b="1" i="0">
+                <a:solidFill>
+                  <a:srgbClr val="97BC62"/>
+                </a:solidFill>
+                <a:latin typeface="Calibri"/>
+              </a:rPr>
+              <a:t>•  </a:t>
+            </a:r>
+            <a:r>
+              <a:rPr sz="2000" b="0" i="0">
+                <a:solidFill>
+                  <a:srgbClr val="222B22"/>
+                </a:solidFill>
+                <a:latin typeface="Calibri"/>
+              </a:rPr>
+              <a:t>Going back changes things — the garden is not a photograph; it is a living place, because your heart is</a:t>
+            </a:r>
+          </a:p>
+          <a:p>
+            <a:pPr marL="274320" indent="-274320">
+              <a:spcAft>
+                <a:spcPts val="800"/>
+              </a:spcAft>
+            </a:pPr>
+            <a:r>
+              <a:rPr sz="2000" b="1" i="0">
+                <a:solidFill>
+                  <a:srgbClr val="97BC62"/>
+                </a:solidFill>
+                <a:latin typeface="Calibri"/>
+              </a:rPr>
+              <a:t>•  </a:t>
+            </a:r>
+            <a:r>
+              <a:rPr sz="2000" b="0" i="0">
+                <a:solidFill>
+                  <a:srgbClr val="222B22"/>
+                </a:solidFill>
+                <a:latin typeface="Calibri"/>
+              </a:rPr>
+              <a:t>A hard garden last week? Going back in tonight is optional — sit and pray instead, fully honored, no explanation owed</a:t>
+            </a:r>
+          </a:p>
+          <a:p>
+            <a:pPr marL="274320" indent="-274320">
+              <a:spcAft>
+                <a:spcPts val="800"/>
+              </a:spcAft>
+            </a:pPr>
+            <a:r>
+              <a:rPr sz="2000" b="1" i="0">
+                <a:solidFill>
+                  <a:srgbClr val="97BC62"/>
+                </a:solidFill>
+                <a:latin typeface="Calibri"/>
+              </a:rPr>
+              <a:t>•  </a:t>
+            </a:r>
+            <a:r>
+              <a:rPr sz="2000" b="0" i="0">
+                <a:solidFill>
+                  <a:srgbClr val="222B22"/>
+                </a:solidFill>
+                <a:latin typeface="Calibri"/>
+              </a:rPr>
+              <a:t>“The words get you to the gate; the silence is where He meets you.”</a:t>
+            </a:r>
+          </a:p>
+        </p:txBody>
+      </p:sp>
+      <p:sp>
+        <p:nvSpPr>
+          <p:cNvPr id="6" name="TextBox 6"/>
+          <p:cNvSpPr txBox="1"/>
+          <p:nvPr/>
+        </p:nvSpPr>
+        <p:spPr>
+          <a:xfrm>
+            <a:off x="6766560" y="1737360"/>
+            <a:ext cx="4663440" cy="2194560"/>
+          </a:xfrm>
+          <a:prstGeom prst="rect">
+            <a:avLst/>
+          </a:prstGeom>
+          <a:solidFill>
+            <a:srgbClr val="F1F6EC"/>
+          </a:solidFill>
+        </p:spPr>
+        <p:txBody>
+          <a:bodyPr wrap="square" lIns="91440" tIns="91440" rIns="91440" bIns="91440" anchor="ctr"/>
+          <a:lstStyle/>
+          <a:p>
+            <a:pPr>
+              <a:spcAft>
+                <a:spcPts val="900"/>
+              </a:spcAft>
+            </a:pPr>
+            <a:r>
+              <a:rPr sz="1200" b="1" i="0">
+                <a:solidFill>
+                  <a:srgbClr val="97BC62"/>
+                </a:solidFill>
+                <a:latin typeface="Calibri"/>
+              </a:rPr>
+              <a:t>PSALM 23:1–3</a:t>
+            </a:r>
+          </a:p>
+          <a:p>
+            <a:pPr>
+              <a:spcAft>
+                <a:spcPts val="600"/>
+              </a:spcAft>
+            </a:pPr>
+            <a:r>
+              <a:rPr sz="2400" b="0" i="1">
+                <a:solidFill>
+                  <a:srgbClr val="222B22"/>
+                </a:solidFill>
+                <a:latin typeface="Cambria"/>
+              </a:rPr>
+              <a:t>“The Lord is my shepherd; I shall not want. He makes me lie down in green pastures. He leads me beside still waters. He restores my soul.”</a:t>
+            </a:r>
+          </a:p>
+        </p:txBody>
+      </p:sp>
+      <p:sp>
+        <p:nvSpPr>
+          <p:cNvPr id="90" name="SlideNum"/>
+          <p:cNvSpPr txBox="1"/>
+          <p:nvPr/>
+        </p:nvSpPr>
+        <p:spPr>
+          <a:xfrm>
+            <a:off x="11384280" y="6446520"/>
+            <a:ext cx="640080" cy="292608"/>
+          </a:xfrm>
+          <a:prstGeom prst="rect">
+            <a:avLst/>
+          </a:prstGeom>
+          <a:noFill/>
+        </p:spPr>
+        <p:txBody>
+          <a:bodyPr wrap="none" lIns="0" tIns="0" rIns="45720" bIns="0" anchor="ctr"/>
+          <a:lstStyle/>
+          <a:p>
+            <a:pPr algn="r"/>
+            <a:r>
+              <a:t>130</a:t>
+            </a:r>
+            <a:endParaRPr sz="1000" b="1">
+              <a:solidFill>
+                <a:srgbClr val="7A8A6E"/>
+              </a:solidFill>
+              <a:latin typeface="Calibri"/>
+            </a:endParaRPr>
+          </a:p>
+        </p:txBody>
+      </p:sp>
+    </p:spTree>
+  </p:cSld>
+  <p:clrMapOvr>
+    <a:masterClrMapping/>
+  </p:clrMapOvr>
+</p:sld>
+</file>
+
+<file path=ppt/slides/slide8.xml><?xml version="1.0" encoding="utf-8"?>
+<p:sld xmlns:a="http://schemas.openxmlformats.org/drawingml/2006/main" xmlns:r="http://schemas.openxmlformats.org/officeDocument/2006/relationships" xmlns:p="http://schemas.openxmlformats.org/presentationml/2006/main">
+  <p:cSld>
+    <p:spTree>
+      <p:nvGrpSpPr>
+        <p:cNvPr id="1" name=""/>
+        <p:cNvGrpSpPr/>
+        <p:nvPr/>
+      </p:nvGrpSpPr>
+      <p:grpSpPr>
+        <a:xfrm>
+          <a:off x="0" y="0"/>
+          <a:ext cx="0" cy="0"/>
+          <a:chOff x="0" y="0"/>
+          <a:chExt cx="0" cy="0"/>
+        </a:xfrm>
+      </p:grpSpPr>
+      <p:sp>
+        <p:nvSpPr>
+          <p:cNvPr id="2" name="Rectangle 1"/>
+          <p:cNvSpPr/>
+          <p:nvPr/>
+        </p:nvSpPr>
+        <p:spPr>
+          <a:xfrm>
+            <a:off x="0" y="0"/>
+            <a:ext cx="12191695" cy="6858000"/>
+          </a:xfrm>
+          <a:prstGeom prst="rect">
+            <a:avLst/>
+          </a:prstGeom>
+          <a:solidFill>
+            <a:srgbClr val="FFFFFF"/>
+          </a:solidFill>
+          <a:ln>
+            <a:noFill/>
+          </a:ln>
+        </p:spPr>
+        <p:txBody>
+          <a:bodyPr/>
+          <a:lstStyle/>
+          <a:p>
+            <a:endParaRPr/>
+          </a:p>
+        </p:txBody>
+      </p:sp>
+      <p:sp>
+        <p:nvSpPr>
+          <p:cNvPr id="3" name="TextBox 2"/>
+          <p:cNvSpPr txBox="1"/>
+          <p:nvPr/>
+        </p:nvSpPr>
+        <p:spPr>
+          <a:xfrm>
+            <a:off x="822960" y="502920"/>
+            <a:ext cx="10515600" cy="822960"/>
+          </a:xfrm>
+          <a:prstGeom prst="rect">
+            <a:avLst/>
+          </a:prstGeom>
+          <a:noFill/>
+        </p:spPr>
+        <p:txBody>
+          <a:bodyPr wrap="square">
+            <a:spAutoFit/>
+          </a:bodyPr>
+          <a:lstStyle/>
+          <a:p>
+            <a:pPr algn="l">
+              <a:spcAft>
+                <a:spcPts val="600"/>
+              </a:spcAft>
+            </a:pPr>
+            <a:r>
+              <a:rPr sz="2800" b="1" i="0">
+                <a:solidFill>
+                  <a:srgbClr val="2C5F2D"/>
+                </a:solidFill>
+                <a:latin typeface="Cambria"/>
+              </a:rPr>
               <a:t>Bridge to the Exercise</a:t>
             </a:r>
           </a:p>
@@ -8293,7 +8565,7 @@
 </p:sld>
 </file>
 
-<file path=ppt/slides/slide8.xml><?xml version="1.0" encoding="utf-8"?>
+<file path=ppt/slides/slide9.xml><?xml version="1.0" encoding="utf-8"?>
 <p:sld xmlns:a="http://schemas.openxmlformats.org/drawingml/2006/main" xmlns:r="http://schemas.openxmlformats.org/officeDocument/2006/relationships" xmlns:p="http://schemas.openxmlformats.org/presentationml/2006/main">
   <p:cSld>
     <p:spTree>
@@ -8618,278 +8890,6 @@
           </a:effectLst>
         </p:spPr>
       </p:pic>
-    </p:spTree>
-  </p:cSld>
-  <p:clrMapOvr>
-    <a:masterClrMapping/>
-  </p:clrMapOvr>
-</p:sld>
-</file>
-
-<file path=ppt/slides/slide9.xml><?xml version="1.0" encoding="utf-8"?>
-<p:sld xmlns:a="http://schemas.openxmlformats.org/drawingml/2006/main" xmlns:r="http://schemas.openxmlformats.org/officeDocument/2006/relationships" xmlns:p="http://schemas.openxmlformats.org/presentationml/2006/main">
-  <p:cSld>
-    <p:spTree>
-      <p:nvGrpSpPr>
-        <p:cNvPr id="1" name=""/>
-        <p:cNvGrpSpPr/>
-        <p:nvPr/>
-      </p:nvGrpSpPr>
-      <p:grpSpPr>
-        <a:xfrm>
-          <a:off x="0" y="0"/>
-          <a:ext cx="0" cy="0"/>
-          <a:chOff x="0" y="0"/>
-          <a:chExt cx="0" cy="0"/>
-        </a:xfrm>
-      </p:grpSpPr>
-      <p:sp>
-        <p:nvSpPr>
-          <p:cNvPr id="2" name="Rectangle 1"/>
-          <p:cNvSpPr/>
-          <p:nvPr/>
-        </p:nvSpPr>
-        <p:spPr>
-          <a:xfrm>
-            <a:off x="0" y="0"/>
-            <a:ext cx="12191695" cy="6858000"/>
-          </a:xfrm>
-          <a:prstGeom prst="rect">
-            <a:avLst/>
-          </a:prstGeom>
-          <a:solidFill>
-            <a:srgbClr val="FFFFFF"/>
-          </a:solidFill>
-          <a:ln>
-            <a:noFill/>
-          </a:ln>
-        </p:spPr>
-        <p:txBody>
-          <a:bodyPr/>
-          <a:lstStyle/>
-          <a:p>
-            <a:endParaRPr/>
-          </a:p>
-        </p:txBody>
-      </p:sp>
-      <p:sp>
-        <p:nvSpPr>
-          <p:cNvPr id="3" name="TextBox 2"/>
-          <p:cNvSpPr txBox="1"/>
-          <p:nvPr/>
-        </p:nvSpPr>
-        <p:spPr>
-          <a:xfrm>
-            <a:off x="822960" y="502920"/>
-            <a:ext cx="10515600" cy="822960"/>
-          </a:xfrm>
-          <a:prstGeom prst="rect">
-            <a:avLst/>
-          </a:prstGeom>
-          <a:noFill/>
-        </p:spPr>
-        <p:txBody>
-          <a:bodyPr wrap="square">
-            <a:spAutoFit/>
-          </a:bodyPr>
-          <a:lstStyle/>
-          <a:p>
-            <a:pPr algn="l">
-              <a:spcAft>
-                <a:spcPts val="600"/>
-              </a:spcAft>
-            </a:pPr>
-            <a:r>
-              <a:rPr sz="2800" b="1" i="0">
-                <a:solidFill>
-                  <a:srgbClr val="2C5F2D"/>
-                </a:solidFill>
-                <a:latin typeface="Cambria"/>
-              </a:rPr>
-              <a:t>Merge and One-Word Landing</a:t>
-            </a:r>
-          </a:p>
-        </p:txBody>
-      </p:sp>
-      <p:sp>
-        <p:nvSpPr>
-          <p:cNvPr id="4" name="TextBox 4"/>
-          <p:cNvSpPr txBox="1"/>
-          <p:nvPr/>
-        </p:nvSpPr>
-        <p:spPr>
-          <a:xfrm>
-            <a:off x="822960" y="1554480"/>
-            <a:ext cx="10515600" cy="4892040"/>
-          </a:xfrm>
-          <a:prstGeom prst="rect">
-            <a:avLst/>
-          </a:prstGeom>
-          <a:noFill/>
-        </p:spPr>
-        <p:txBody>
-          <a:bodyPr wrap="square" lIns="91440" tIns="91440" rIns="91440" bIns="91440"/>
-          <a:lstStyle/>
-          <a:p>
-            <a:pPr marL="274320" indent="-274320">
-              <a:spcAft>
-                <a:spcPts val="900"/>
-              </a:spcAft>
-            </a:pPr>
-            <a:r>
-              <a:rPr sz="2800" b="1" i="0">
-                <a:solidFill>
-                  <a:srgbClr val="97BC62"/>
-                </a:solidFill>
-                <a:latin typeface="Calibri"/>
-              </a:rPr>
-              <a:t>•  </a:t>
-            </a:r>
-            <a:r>
-              <a:rPr sz="2800" b="0" i="0">
-                <a:solidFill>
-                  <a:srgbClr val="222B22"/>
-                </a:solidFill>
-                <a:latin typeface="Calibri"/>
-              </a:rPr>
-              <a:t>“What happened in your pair stays in your pair.”</a:t>
-            </a:r>
-          </a:p>
-          <a:p>
-            <a:pPr marL="274320" indent="-274320">
-              <a:spcAft>
-                <a:spcPts val="900"/>
-              </a:spcAft>
-            </a:pPr>
-            <a:r>
-              <a:rPr sz="2800" b="1" i="0">
-                <a:solidFill>
-                  <a:srgbClr val="97BC62"/>
-                </a:solidFill>
-                <a:latin typeface="Calibri"/>
-              </a:rPr>
-              <a:t>•  </a:t>
-            </a:r>
-            <a:r>
-              <a:rPr sz="2800" b="0" i="0">
-                <a:solidFill>
-                  <a:srgbClr val="222B22"/>
-                </a:solidFill>
-                <a:latin typeface="Calibri"/>
-              </a:rPr>
-              <a:t>One word each, when you’re ready — not what was said, but what you noticed; you can pass</a:t>
-            </a:r>
-          </a:p>
-          <a:p>
-            <a:pPr marL="685800" indent="-274320">
-              <a:spcAft>
-                <a:spcPts val="700"/>
-              </a:spcAft>
-            </a:pPr>
-            <a:r>
-              <a:rPr sz="2000" b="1" i="0">
-                <a:solidFill>
-                  <a:srgbClr val="97BC62"/>
-                </a:solidFill>
-                <a:latin typeface="Calibri"/>
-              </a:rPr>
-              <a:t>–  </a:t>
-            </a:r>
-            <a:r>
-              <a:rPr sz="2000" b="0" i="1">
-                <a:solidFill>
-                  <a:srgbClr val="222B22"/>
-                </a:solidFill>
-                <a:latin typeface="Calibri"/>
-              </a:rPr>
-              <a:t>“Deeper.” “Same.” “Tender.” “Quiet.” “Harder.” “Found.”</a:t>
-            </a:r>
-          </a:p>
-          <a:p>
-            <a:pPr marL="274320" indent="-274320">
-              <a:spcAft>
-                <a:spcPts val="900"/>
-              </a:spcAft>
-            </a:pPr>
-            <a:r>
-              <a:rPr sz="2800" b="1" i="0">
-                <a:solidFill>
-                  <a:srgbClr val="97BC62"/>
-                </a:solidFill>
-                <a:latin typeface="Calibri"/>
-              </a:rPr>
-              <a:t>•  </a:t>
-            </a:r>
-            <a:r>
-              <a:rPr sz="2800" b="0" i="0">
-                <a:solidFill>
-                  <a:srgbClr val="222B22"/>
-                </a:solidFill>
-                <a:latin typeface="Calibri"/>
-              </a:rPr>
-              <a:t>A parent offers the first word — each one received without commentary</a:t>
-            </a:r>
-          </a:p>
-          <a:p>
-            <a:pPr marL="274320" indent="-274320">
-              <a:spcAft>
-                <a:spcPts val="900"/>
-              </a:spcAft>
-            </a:pPr>
-            <a:r>
-              <a:rPr sz="2800" b="1" i="0">
-                <a:solidFill>
-                  <a:srgbClr val="97BC62"/>
-                </a:solidFill>
-                <a:latin typeface="Calibri"/>
-              </a:rPr>
-              <a:t>•  </a:t>
-            </a:r>
-            <a:r>
-              <a:rPr sz="2800" b="0" i="0">
-                <a:solidFill>
-                  <a:srgbClr val="222B22"/>
-                </a:solidFill>
-                <a:latin typeface="Calibri"/>
-              </a:rPr>
-              <a:t>“A garden visited twice is a garden being tended. Whatever He is doing in yours, He will keep doing it this week.”</a:t>
-            </a:r>
-          </a:p>
-        </p:txBody>
-      </p:sp>
-      <p:sp>
-        <p:nvSpPr>
-          <p:cNvPr id="90" name="SlideNum"/>
-          <p:cNvSpPr txBox="1"/>
-          <p:nvPr/>
-        </p:nvSpPr>
-        <p:spPr>
-          <a:xfrm>
-            <a:off x="11384280" y="6446520"/>
-            <a:ext cx="640080" cy="292608"/>
-          </a:xfrm>
-          <a:prstGeom prst="rect">
-            <a:avLst/>
-          </a:prstGeom>
-          <a:noFill/>
-        </p:spPr>
-        <p:txBody>
-          <a:bodyPr wrap="none" lIns="0" tIns="0" rIns="45720" bIns="0" anchor="ctr"/>
-          <a:lstStyle/>
-          <a:p>
-            <a:pPr algn="r"/>
-            <a:r>
-              <a:t>133</a:t>
-            </a:r>
-            <a:endParaRPr sz="1000" b="1">
-              <a:solidFill>
-                <a:srgbClr val="7A8A6E"/>
-              </a:solidFill>
-              <a:latin typeface="Calibri"/>
-            </a:endParaRPr>
-          </a:p>
-        </p:txBody>
-      </p:sp>
     </p:spTree>
   </p:cSld>
   <p:clrMapOvr>

</xml_diff>

<commit_message>
v2.24 (John's word, 8 October): Session 6's debrief — groups, the three words, the numbers
Small groups by gender become the default breakout (pairs or one circle by
the leaders' judgement); a new slide for the place, the pattern, the pull;
the three questions printed on The Road So Far (still one page) and pointed
to from the take-home; on-screen repeats trimmed; S6 run sheet and page in
step; timings re-cut, still ending 8:30.

Leader notes for every session are now built from the decks' own speaker
notes (tools/build-evening-leader-notes.py): each block leads with the
on-screen corner number ("Title" for the series title slide) and is
colour-coded by lead, with distinct bar styles for black-and-white. Fixes
S1 and S12, whose notes had skipped a later-added slide. Master numbering
rerun: S6 81-98, every later session +1, series ends at 322.

Co-Authored-By: Claude Opus 5.5 <noreply@anthropic.com>
</commit_message>
<xml_diff>
--- a/_implementation-notes/evening-series/FotH Evening Session 10 Slides DRAFT v1.pptx
+++ b/_implementation-notes/evening-series/FotH Evening Session 10 Slides DRAFT v1.pptx
@@ -5028,7 +5028,7 @@
           <a:p>
             <a:pPr algn="r"/>
             <a:r>
-              <a:t>152</a:t>
+              <a:t>153</a:t>
             </a:r>
             <a:endParaRPr sz="1000" b="1">
               <a:solidFill>
@@ -5300,7 +5300,7 @@
           <a:p>
             <a:pPr algn="r"/>
             <a:r>
-              <a:t>153</a:t>
+              <a:t>154</a:t>
             </a:r>
             <a:endParaRPr sz="1000" b="1">
               <a:solidFill>
@@ -5528,7 +5528,7 @@
           <a:p>
             <a:pPr algn="r"/>
             <a:r>
-              <a:t>154</a:t>
+              <a:t>155</a:t>
             </a:r>
             <a:endParaRPr sz="1000" b="1">
               <a:solidFill>
@@ -5720,7 +5720,7 @@
           <a:p>
             <a:pPr algn="r"/>
             <a:r>
-              <a:t>155</a:t>
+              <a:t>156</a:t>
             </a:r>
             <a:endParaRPr sz="1000" b="1">
               <a:solidFill>
@@ -6017,7 +6017,7 @@
           <a:p>
             <a:pPr algn="r"/>
             <a:r>
-              <a:t>156</a:t>
+              <a:t>157</a:t>
             </a:r>
             <a:endParaRPr sz="1000" b="1">
               <a:solidFill>
@@ -6462,7 +6462,7 @@
           <a:p>
             <a:pPr algn="r"/>
             <a:r>
-              <a:t>157</a:t>
+              <a:t>158</a:t>
             </a:r>
             <a:endParaRPr sz="1000" b="1">
               <a:solidFill>
@@ -6711,7 +6711,7 @@
           <a:p>
             <a:pPr algn="r"/>
             <a:r>
-              <a:t>144</a:t>
+              <a:t>145</a:t>
             </a:r>
             <a:endParaRPr sz="1000" b="1">
               <a:solidFill>
@@ -6892,7 +6892,7 @@
           <a:p>
             <a:pPr algn="r"/>
             <a:r>
-              <a:t>145</a:t>
+              <a:t>146</a:t>
             </a:r>
             <a:endParaRPr sz="1000" b="1">
               <a:solidFill>
@@ -7306,7 +7306,7 @@
           <a:p>
             <a:pPr algn="r"/>
             <a:r>
-              <a:t>146</a:t>
+              <a:t>147</a:t>
             </a:r>
             <a:endParaRPr sz="1000" b="1">
               <a:solidFill>
@@ -7689,7 +7689,7 @@
           <a:p>
             <a:pPr algn="r"/>
             <a:r>
-              <a:t>147</a:t>
+              <a:t>148</a:t>
             </a:r>
             <a:endParaRPr sz="1000" b="1">
               <a:solidFill>
@@ -7936,7 +7936,7 @@
           <a:p>
             <a:pPr algn="r"/>
             <a:r>
-              <a:t>148</a:t>
+              <a:t>149</a:t>
             </a:r>
             <a:endParaRPr sz="1000" b="1">
               <a:solidFill>
@@ -8299,7 +8299,7 @@
           <a:p>
             <a:pPr algn="r"/>
             <a:r>
-              <a:t>149</a:t>
+              <a:t>150</a:t>
             </a:r>
             <a:endParaRPr sz="1000" b="1">
               <a:solidFill>
@@ -8546,7 +8546,7 @@
           <a:p>
             <a:pPr algn="r"/>
             <a:r>
-              <a:t>150</a:t>
+              <a:t>151</a:t>
             </a:r>
             <a:endParaRPr sz="1000" b="1">
               <a:solidFill>
@@ -8843,7 +8843,7 @@
           <a:p>
             <a:pPr algn="r"/>
             <a:r>
-              <a:t>151</a:t>
+              <a:t>152</a:t>
             </a:r>
             <a:endParaRPr sz="1000" b="1">
               <a:solidFill>

</xml_diff>